<commit_message>
Replace narrative perspective slides with Trevor and Kelly characterizations
Co-Authored-By: Claude Opus 5.5 <noreply@anthropic.com>
Claude-Session: https://claude.ai/code/session_01QCEJR44cc2V7cux98HejmK
</commit_message>
<xml_diff>
--- a/bracelet/The_Bracelet.pptx
+++ b/bracelet/The_Bracelet.pptx
@@ -110,22 +110,22 @@
   <p:extLst>
     <p:ext uri="{521415D9-36F7-43E2-AB2F-B90AF26B5E84}">
       <p14:sectionLst xmlns:p14="http://schemas.microsoft.com/office/powerpoint/2010/main">
-        <p14:section name="Summary" id="{e323643b-5b02-4c12-2c4b-6c4b993f1791}">
+        <p14:section name="Summary" id="{bde120a2-e795-0504-805e-4b8e90dec4b4}">
           <p14:sldIdLst>
             <p14:sldId id="256"/>
           </p14:sldIdLst>
         </p14:section>
-        <p14:section name="Short story" id="{17153705-6058-8272-2a1b-f68c5a6f0f47}">
+        <p14:section name="Short story" id="{71124188-0e72-d458-9480-a1dd5f84c491}">
           <p14:sldIdLst>
             <p14:sldId id="257"/>
           </p14:sldIdLst>
         </p14:section>
-        <p14:section name="Effect" id="{e4078d63-a24d-342b-1be6-7be770b8f9a6}">
+        <p14:section name="Trevor" id="{51de7671-258d-90af-2edf-2c0b5ff1d831}">
           <p14:sldIdLst>
             <p14:sldId id="258"/>
           </p14:sldIdLst>
         </p14:section>
-        <p14:section name="Perspective" id="{80b7636a-a5aa-b832-0e0c-4900a12bf92f}">
+        <p14:section name="Kelly" id="{4e36d3de-c3ad-42d9-9fd0-36bb54e3c4c1}">
           <p14:sldIdLst>
             <p14:sldId id="259"/>
           </p14:sldIdLst>
@@ -3230,7 +3230,7 @@
                   <a:schemeClr val="accent1"/>
                 </a:solidFill>
               </a:rPr>
-              <a:t>NARRATIVE PERSPECTIVE</a:t>
+              <a:t>CHARACTERIZATION</a:t>
             </a:r>
             <a:endParaRPr lang="en-US" sz="1100" dirty="0"/>
           </a:p>
@@ -3271,7 +3271,7 @@
                 <a:ea typeface="Cambria" pitchFamily="34" charset="-122"/>
                 <a:cs typeface="Cambria" pitchFamily="34" charset="-120"/>
               </a:rPr>
-              <a:t>Effect of the perspective</a:t>
+              <a:t>Who is Trevor?</a:t>
             </a:r>
             <a:endParaRPr lang="en-US" sz="3400" dirty="0"/>
           </a:p>
@@ -3392,135 +3392,14 @@
       </p:sp>
       <p:sp>
         <p:nvSpPr>
-          <p:cNvPr id="9" name="Closeness &amp; identification circle"/>
-          <p:cNvSpPr/>
-          <p:nvPr/>
-        </p:nvSpPr>
-        <p:spPr>
-          <a:xfrm>
-            <a:off x="457200" y="1234440"/>
-            <a:ext cx="548640" cy="548640"/>
-          </a:xfrm>
-          <a:prstGeom prst="ellipse">
-            <a:avLst/>
-          </a:prstGeom>
-          <a:solidFill>
-            <a:schemeClr val="accent1"/>
-          </a:solidFill>
-          <a:ln w="12700">
-            <a:solidFill>
-              <a:schemeClr val="accent1"/>
-            </a:solidFill>
-            <a:prstDash val="solid"/>
-          </a:ln>
-        </p:spPr>
-      </p:sp>
-      <p:pic>
-        <p:nvPicPr>
-          <p:cNvPr id="10" name="Closeness &amp; identification icon" descr="preencoded.png">    </p:cNvPr>
-          <p:cNvPicPr>
-            <a:picLocks noChangeAspect="1"/>
-          </p:cNvPicPr>
-          <p:nvPr/>
-        </p:nvPicPr>
-        <p:blipFill>
-          <a:blip r:embed="rId1"/>
-          <a:stretch>
-            <a:fillRect/>
-          </a:stretch>
-        </p:blipFill>
-        <p:spPr>
-          <a:xfrm>
-            <a:off x="594360" y="1371600"/>
-            <a:ext cx="274320" cy="274320"/>
-          </a:xfrm>
-          <a:prstGeom prst="rect">
-            <a:avLst/>
-          </a:prstGeom>
-        </p:spPr>
-      </p:pic>
-      <p:sp>
-        <p:nvSpPr>
-          <p:cNvPr id="11" name="Closeness &amp;amp; identification header"/>
-          <p:cNvSpPr txBox="1"/>
-          <p:nvPr/>
-        </p:nvSpPr>
-        <p:spPr>
-          <a:xfrm>
-            <a:off x="1188720" y="1188720"/>
-            <a:ext cx="4206240" cy="320040"/>
-          </a:xfrm>
-          <a:prstGeom prst="rect">
-            <a:avLst/>
-          </a:prstGeom>
-          <a:noFill/>
-          <a:ln/>
-        </p:spPr>
-        <p:txBody>
-          <a:bodyPr wrap="square" lIns="0" tIns="0" rIns="0" bIns="0" rtlCol="0" anchor="ctr"/>
-          <a:lstStyle/>
-          <a:p>
-            <a:pPr indent="0" marL="0">
-              <a:buNone/>
-            </a:pPr>
-            <a:r>
-              <a:rPr lang="en-US" sz="1500" b="1" dirty="0">
-                <a:solidFill>
-                  <a:schemeClr val="bg1"/>
-                </a:solidFill>
-              </a:rPr>
-              <a:t>Closeness &amp; identification</a:t>
-            </a:r>
-            <a:endParaRPr lang="en-US" sz="1500" dirty="0"/>
-          </a:p>
-        </p:txBody>
-      </p:sp>
-      <p:sp>
-        <p:nvSpPr>
-          <p:cNvPr id="12" name="Closeness &amp;amp; identification text"/>
-          <p:cNvSpPr txBox="1"/>
-          <p:nvPr/>
-        </p:nvSpPr>
-        <p:spPr>
-          <a:xfrm>
-            <a:off x="1188720" y="1508760"/>
-            <a:ext cx="4206240" cy="502920"/>
-          </a:xfrm>
-          <a:prstGeom prst="rect">
-            <a:avLst/>
-          </a:prstGeom>
-          <a:noFill/>
-          <a:ln/>
-        </p:spPr>
-        <p:txBody>
-          <a:bodyPr wrap="square" lIns="0" tIns="0" rIns="0" bIns="0" rtlCol="0" anchor="t"/>
-          <a:lstStyle/>
-          <a:p>
-            <a:pPr indent="0" marL="0">
-              <a:buNone/>
-            </a:pPr>
-            <a:r>
-              <a:rPr lang="en-US" sz="1300" dirty="0">
-                <a:solidFill>
-                  <a:schemeClr val="accent2"/>
-                </a:solidFill>
-              </a:rPr>
-              <a:t>We share Kelly’s thoughts and feelings (“the blush that warmed my face”).</a:t>
-            </a:r>
-            <a:endParaRPr lang="en-US" sz="1300" dirty="0"/>
-          </a:p>
-        </p:txBody>
-      </p:sp>
-      <p:sp>
-        <p:nvSpPr>
-          <p:cNvPr id="13" name="Suspense through limited knowledge circle"/>
-          <p:cNvSpPr/>
-          <p:nvPr/>
-        </p:nvSpPr>
-        <p:spPr>
-          <a:xfrm>
-            <a:off x="457200" y="2130552"/>
-            <a:ext cx="548640" cy="548640"/>
+          <p:cNvPr id="9" name="Portrait circle"/>
+          <p:cNvSpPr/>
+          <p:nvPr/>
+        </p:nvSpPr>
+        <p:spPr>
+          <a:xfrm>
+            <a:off x="548640" y="1371600"/>
+            <a:ext cx="1737360" cy="1737360"/>
           </a:xfrm>
           <a:prstGeom prst="ellipse">
             <a:avLst/>
@@ -3536,40 +3415,16 @@
           </a:ln>
         </p:spPr>
       </p:sp>
-      <p:pic>
-        <p:nvPicPr>
-          <p:cNvPr id="14" name="Suspense through limited knowledge icon" descr="preencoded.png">    </p:cNvPr>
-          <p:cNvPicPr>
-            <a:picLocks noChangeAspect="1"/>
-          </p:cNvPicPr>
-          <p:nvPr/>
-        </p:nvPicPr>
-        <p:blipFill>
-          <a:blip r:embed="rId2"/>
-          <a:stretch>
-            <a:fillRect/>
-          </a:stretch>
-        </p:blipFill>
-        <p:spPr>
-          <a:xfrm>
-            <a:off x="594360" y="2267712"/>
-            <a:ext cx="274320" cy="274320"/>
-          </a:xfrm>
-          <a:prstGeom prst="rect">
-            <a:avLst/>
-          </a:prstGeom>
-        </p:spPr>
-      </p:pic>
-      <p:sp>
-        <p:nvSpPr>
-          <p:cNvPr id="15" name="Suspense through limited knowledge header"/>
+      <p:sp>
+        <p:nvSpPr>
+          <p:cNvPr id="10" name="Portrait initial"/>
           <p:cNvSpPr txBox="1"/>
           <p:nvPr/>
         </p:nvSpPr>
         <p:spPr>
           <a:xfrm>
-            <a:off x="1188720" y="2084832"/>
-            <a:ext cx="4206240" cy="320040"/>
+            <a:off x="548640" y="1371600"/>
+            <a:ext cx="1737360" cy="1737360"/>
           </a:xfrm>
           <a:prstGeom prst="rect">
             <a:avLst/>
@@ -3581,31 +3436,34 @@
           <a:bodyPr wrap="square" lIns="0" tIns="0" rIns="0" bIns="0" rtlCol="0" anchor="ctr"/>
           <a:lstStyle/>
           <a:p>
-            <a:pPr indent="0" marL="0">
-              <a:buNone/>
-            </a:pPr>
-            <a:r>
-              <a:rPr lang="en-US" sz="1500" b="1" dirty="0">
+            <a:pPr algn="ctr" indent="0" marL="0">
+              <a:buNone/>
+            </a:pPr>
+            <a:r>
+              <a:rPr lang="en-US" sz="7200" b="1" dirty="0">
                 <a:solidFill>
                   <a:schemeClr val="bg1"/>
                 </a:solidFill>
-              </a:rPr>
-              <a:t>Suspense through limited knowledge</a:t>
-            </a:r>
-            <a:endParaRPr lang="en-US" sz="1500" dirty="0"/>
-          </a:p>
-        </p:txBody>
-      </p:sp>
-      <p:sp>
-        <p:nvSpPr>
-          <p:cNvPr id="16" name="Suspense through limited knowledge text"/>
+                <a:latin typeface="Cambria" pitchFamily="34" charset="0"/>
+                <a:ea typeface="Cambria" pitchFamily="34" charset="-122"/>
+                <a:cs typeface="Cambria" pitchFamily="34" charset="-120"/>
+              </a:rPr>
+              <a:t>T</a:t>
+            </a:r>
+            <a:endParaRPr lang="en-US" sz="7200" dirty="0"/>
+          </a:p>
+        </p:txBody>
+      </p:sp>
+      <p:sp>
+        <p:nvSpPr>
+          <p:cNvPr id="11" name="Name"/>
           <p:cNvSpPr txBox="1"/>
           <p:nvPr/>
         </p:nvSpPr>
         <p:spPr>
           <a:xfrm>
-            <a:off x="1188720" y="2404872"/>
-            <a:ext cx="4206240" cy="502920"/>
+            <a:off x="365760" y="3291840"/>
+            <a:ext cx="2103120" cy="365760"/>
           </a:xfrm>
           <a:prstGeom prst="rect">
             <a:avLst/>
@@ -3614,280 +3472,74 @@
           <a:ln/>
         </p:spPr>
         <p:txBody>
+          <a:bodyPr wrap="square" lIns="0" tIns="0" rIns="0" bIns="0" rtlCol="0" anchor="ctr"/>
+          <a:lstStyle/>
+          <a:p>
+            <a:pPr algn="ctr" indent="0" marL="0">
+              <a:buNone/>
+            </a:pPr>
+            <a:r>
+              <a:rPr lang="en-US" sz="2000" b="1" dirty="0">
+                <a:solidFill>
+                  <a:schemeClr val="bg1"/>
+                </a:solidFill>
+              </a:rPr>
+              <a:t>Trevor</a:t>
+            </a:r>
+            <a:endParaRPr lang="en-US" sz="2000" dirty="0"/>
+          </a:p>
+        </p:txBody>
+      </p:sp>
+      <p:sp>
+        <p:nvSpPr>
+          <p:cNvPr id="12" name="Role"/>
+          <p:cNvSpPr txBox="1"/>
+          <p:nvPr/>
+        </p:nvSpPr>
+        <p:spPr>
+          <a:xfrm>
+            <a:off x="365760" y="3657600"/>
+            <a:ext cx="2103120" cy="548640"/>
+          </a:xfrm>
+          <a:prstGeom prst="rect">
+            <a:avLst/>
+          </a:prstGeom>
+          <a:noFill/>
+          <a:ln/>
+        </p:spPr>
+        <p:txBody>
           <a:bodyPr wrap="square" lIns="0" tIns="0" rIns="0" bIns="0" rtlCol="0" anchor="t"/>
           <a:lstStyle/>
           <a:p>
-            <a:pPr indent="0" marL="0">
-              <a:buNone/>
-            </a:pPr>
-            <a:r>
-              <a:rPr lang="en-US" sz="1300" dirty="0">
+            <a:pPr algn="ctr" indent="0" marL="0">
+              <a:buNone/>
+            </a:pPr>
+            <a:r>
+              <a:rPr lang="en-US" sz="1200" dirty="0">
                 <a:solidFill>
                   <a:schemeClr val="accent2"/>
                 </a:solidFill>
               </a:rPr>
-              <a:t>We only know what Kelly knows – we learn the bracelet is stolen together with her.</a:t>
-            </a:r>
-            <a:endParaRPr lang="en-US" sz="1300" dirty="0"/>
-          </a:p>
-        </p:txBody>
-      </p:sp>
-      <p:sp>
-        <p:nvSpPr>
-          <p:cNvPr id="17" name="Subjective, one-sided view circle"/>
-          <p:cNvSpPr/>
-          <p:nvPr/>
-        </p:nvSpPr>
-        <p:spPr>
-          <a:xfrm>
-            <a:off x="457200" y="3026664"/>
-            <a:ext cx="548640" cy="548640"/>
-          </a:xfrm>
-          <a:prstGeom prst="ellipse">
-            <a:avLst/>
-          </a:prstGeom>
-          <a:solidFill>
-            <a:schemeClr val="accent1"/>
-          </a:solidFill>
-          <a:ln w="12700">
-            <a:solidFill>
-              <a:schemeClr val="accent1"/>
-            </a:solidFill>
-            <a:prstDash val="solid"/>
-          </a:ln>
-        </p:spPr>
-      </p:sp>
-      <p:pic>
-        <p:nvPicPr>
-          <p:cNvPr id="18" name="Subjective, one-sided view icon" descr="preencoded.png">    </p:cNvPr>
-          <p:cNvPicPr>
-            <a:picLocks noChangeAspect="1"/>
-          </p:cNvPicPr>
-          <p:nvPr/>
-        </p:nvPicPr>
-        <p:blipFill>
-          <a:blip r:embed="rId3"/>
-          <a:stretch>
-            <a:fillRect/>
-          </a:stretch>
-        </p:blipFill>
-        <p:spPr>
-          <a:xfrm>
-            <a:off x="594360" y="3163824"/>
-            <a:ext cx="274320" cy="274320"/>
-          </a:xfrm>
-          <a:prstGeom prst="rect">
-            <a:avLst/>
-          </a:prstGeom>
-        </p:spPr>
-      </p:pic>
-      <p:sp>
-        <p:nvSpPr>
-          <p:cNvPr id="19" name="Subjective, one-sided view header"/>
-          <p:cNvSpPr txBox="1"/>
-          <p:nvPr/>
-        </p:nvSpPr>
-        <p:spPr>
-          <a:xfrm>
-            <a:off x="1188720" y="2980944"/>
-            <a:ext cx="4206240" cy="320040"/>
-          </a:xfrm>
-          <a:prstGeom prst="rect">
-            <a:avLst/>
-          </a:prstGeom>
-          <a:noFill/>
-          <a:ln/>
-        </p:spPr>
-        <p:txBody>
-          <a:bodyPr wrap="square" lIns="0" tIns="0" rIns="0" bIns="0" rtlCol="0" anchor="ctr"/>
-          <a:lstStyle/>
-          <a:p>
-            <a:pPr indent="0" marL="0">
-              <a:buNone/>
-            </a:pPr>
-            <a:r>
-              <a:rPr lang="en-US" sz="1500" b="1" dirty="0">
-                <a:solidFill>
-                  <a:schemeClr val="bg1"/>
-                </a:solidFill>
-              </a:rPr>
-              <a:t>Subjective, one-sided view</a:t>
-            </a:r>
-            <a:endParaRPr lang="en-US" sz="1500" dirty="0"/>
-          </a:p>
-        </p:txBody>
-      </p:sp>
-      <p:sp>
-        <p:nvSpPr>
-          <p:cNvPr id="20" name="Subjective, one-sided view text"/>
-          <p:cNvSpPr txBox="1"/>
-          <p:nvPr/>
-        </p:nvSpPr>
-        <p:spPr>
-          <a:xfrm>
-            <a:off x="1188720" y="3300984"/>
-            <a:ext cx="4206240" cy="502920"/>
-          </a:xfrm>
-          <a:prstGeom prst="rect">
-            <a:avLst/>
-          </a:prstGeom>
-          <a:noFill/>
-          <a:ln/>
-        </p:spPr>
-        <p:txBody>
-          <a:bodyPr wrap="square" lIns="0" tIns="0" rIns="0" bIns="0" rtlCol="0" anchor="t"/>
-          <a:lstStyle/>
-          <a:p>
-            <a:pPr indent="0" marL="0">
-              <a:buNone/>
-            </a:pPr>
-            <a:r>
-              <a:rPr lang="en-US" sz="1300" dirty="0">
-                <a:solidFill>
-                  <a:schemeClr val="accent2"/>
-                </a:solidFill>
-              </a:rPr>
-              <a:t>Trevor is seen only through her eyes: “curls that never looked combed.”</a:t>
-            </a:r>
-            <a:endParaRPr lang="en-US" sz="1300" dirty="0"/>
-          </a:p>
-        </p:txBody>
-      </p:sp>
-      <p:sp>
-        <p:nvSpPr>
-          <p:cNvPr id="21" name="Inner conflict made visible circle"/>
-          <p:cNvSpPr/>
-          <p:nvPr/>
-        </p:nvSpPr>
-        <p:spPr>
-          <a:xfrm>
-            <a:off x="457200" y="3922776"/>
-            <a:ext cx="548640" cy="548640"/>
-          </a:xfrm>
-          <a:prstGeom prst="ellipse">
-            <a:avLst/>
-          </a:prstGeom>
-          <a:solidFill>
-            <a:schemeClr val="accent4"/>
-          </a:solidFill>
-          <a:ln w="12700">
-            <a:solidFill>
-              <a:schemeClr val="accent4"/>
-            </a:solidFill>
-            <a:prstDash val="solid"/>
-          </a:ln>
-        </p:spPr>
-      </p:sp>
-      <p:pic>
-        <p:nvPicPr>
-          <p:cNvPr id="22" name="Inner conflict made visible icon" descr="preencoded.png">    </p:cNvPr>
-          <p:cNvPicPr>
-            <a:picLocks noChangeAspect="1"/>
-          </p:cNvPicPr>
-          <p:nvPr/>
-        </p:nvPicPr>
-        <p:blipFill>
-          <a:blip r:embed="rId4"/>
-          <a:stretch>
-            <a:fillRect/>
-          </a:stretch>
-        </p:blipFill>
-        <p:spPr>
-          <a:xfrm>
-            <a:off x="594360" y="4059936"/>
-            <a:ext cx="274320" cy="274320"/>
-          </a:xfrm>
-          <a:prstGeom prst="rect">
-            <a:avLst/>
-          </a:prstGeom>
-        </p:spPr>
-      </p:pic>
-      <p:sp>
-        <p:nvSpPr>
-          <p:cNvPr id="23" name="Inner conflict made visible header"/>
-          <p:cNvSpPr txBox="1"/>
-          <p:nvPr/>
-        </p:nvSpPr>
-        <p:spPr>
-          <a:xfrm>
-            <a:off x="1188720" y="3877056"/>
-            <a:ext cx="4206240" cy="320040"/>
-          </a:xfrm>
-          <a:prstGeom prst="rect">
-            <a:avLst/>
-          </a:prstGeom>
-          <a:noFill/>
-          <a:ln/>
-        </p:spPr>
-        <p:txBody>
-          <a:bodyPr wrap="square" lIns="0" tIns="0" rIns="0" bIns="0" rtlCol="0" anchor="ctr"/>
-          <a:lstStyle/>
-          <a:p>
-            <a:pPr indent="0" marL="0">
-              <a:buNone/>
-            </a:pPr>
-            <a:r>
-              <a:rPr lang="en-US" sz="1500" b="1" dirty="0">
-                <a:solidFill>
-                  <a:schemeClr val="bg1"/>
-                </a:solidFill>
-              </a:rPr>
-              <a:t>Inner conflict made visible</a:t>
-            </a:r>
-            <a:endParaRPr lang="en-US" sz="1500" dirty="0"/>
-          </a:p>
-        </p:txBody>
-      </p:sp>
-      <p:sp>
-        <p:nvSpPr>
-          <p:cNvPr id="24" name="Inner conflict made visible text"/>
-          <p:cNvSpPr txBox="1"/>
-          <p:nvPr/>
-        </p:nvSpPr>
-        <p:spPr>
-          <a:xfrm>
-            <a:off x="1188720" y="4197096"/>
-            <a:ext cx="4206240" cy="502920"/>
-          </a:xfrm>
-          <a:prstGeom prst="rect">
-            <a:avLst/>
-          </a:prstGeom>
-          <a:noFill/>
-          <a:ln/>
-        </p:spPr>
-        <p:txBody>
-          <a:bodyPr wrap="square" lIns="0" tIns="0" rIns="0" bIns="0" rtlCol="0" anchor="t"/>
-          <a:lstStyle/>
-          <a:p>
-            <a:pPr indent="0" marL="0">
-              <a:buNone/>
-            </a:pPr>
-            <a:r>
-              <a:rPr lang="en-US" sz="1300" dirty="0">
-                <a:solidFill>
-                  <a:schemeClr val="accent2"/>
-                </a:solidFill>
-              </a:rPr>
-              <a:t>Her doubts are shown directly: “I wasn’t sure how I felt about him though.”</a:t>
-            </a:r>
-            <a:endParaRPr lang="en-US" sz="1300" dirty="0"/>
-          </a:p>
-        </p:txBody>
-      </p:sp>
-      <p:sp>
-        <p:nvSpPr>
-          <p:cNvPr id="25" name="Quote card"/>
-          <p:cNvSpPr/>
-          <p:nvPr/>
-        </p:nvSpPr>
-        <p:spPr>
-          <a:xfrm>
-            <a:off x="5760720" y="1280160"/>
-            <a:ext cx="2926080" cy="3291840"/>
+              <a:t>Kelly’s new boyfriend</a:t>
+            </a:r>
+            <a:endParaRPr lang="en-US" sz="1200" dirty="0"/>
+          </a:p>
+        </p:txBody>
+      </p:sp>
+      <p:sp>
+        <p:nvSpPr>
+          <p:cNvPr id="13" name="Appearance card"/>
+          <p:cNvSpPr/>
+          <p:nvPr/>
+        </p:nvSpPr>
+        <p:spPr>
+          <a:xfrm>
+            <a:off x="2697480" y="1188720"/>
+            <a:ext cx="2788920" cy="1143000"/>
           </a:xfrm>
           <a:prstGeom prst="roundRect">
             <a:avLst>
-              <a:gd name="adj" fmla="val 3750"/>
+              <a:gd name="adj" fmla="val 9600"/>
             </a:avLst>
           </a:prstGeom>
           <a:solidFill>
@@ -3910,14 +3562,63 @@
       </p:sp>
       <p:sp>
         <p:nvSpPr>
-          <p:cNvPr id="26" name="Quote mark"/>
+          <p:cNvPr id="14" name="Appearance circle"/>
+          <p:cNvSpPr/>
+          <p:nvPr/>
+        </p:nvSpPr>
+        <p:spPr>
+          <a:xfrm>
+            <a:off x="2880360" y="1353312"/>
+            <a:ext cx="411480" cy="411480"/>
+          </a:xfrm>
+          <a:prstGeom prst="ellipse">
+            <a:avLst/>
+          </a:prstGeom>
+          <a:solidFill>
+            <a:schemeClr val="accent4"/>
+          </a:solidFill>
+          <a:ln w="12700">
+            <a:solidFill>
+              <a:schemeClr val="accent4"/>
+            </a:solidFill>
+            <a:prstDash val="solid"/>
+          </a:ln>
+        </p:spPr>
+      </p:sp>
+      <p:pic>
+        <p:nvPicPr>
+          <p:cNvPr id="15" name="Appearance icon" descr="preencoded.png">    </p:cNvPr>
+          <p:cNvPicPr>
+            <a:picLocks noChangeAspect="1"/>
+          </p:cNvPicPr>
+          <p:nvPr/>
+        </p:nvPicPr>
+        <p:blipFill>
+          <a:blip r:embed="rId1"/>
+          <a:stretch>
+            <a:fillRect/>
+          </a:stretch>
+        </p:blipFill>
+        <p:spPr>
+          <a:xfrm>
+            <a:off x="2983230" y="1456182"/>
+            <a:ext cx="205740" cy="205740"/>
+          </a:xfrm>
+          <a:prstGeom prst="rect">
+            <a:avLst/>
+          </a:prstGeom>
+        </p:spPr>
+      </p:pic>
+      <p:sp>
+        <p:nvSpPr>
+          <p:cNvPr id="16" name="Appearance header"/>
           <p:cNvSpPr txBox="1"/>
           <p:nvPr/>
         </p:nvSpPr>
         <p:spPr>
           <a:xfrm>
-            <a:off x="5943600" y="1234440"/>
-            <a:ext cx="914400" cy="914400"/>
+            <a:off x="3429000" y="1353312"/>
+            <a:ext cx="1874520" cy="411480"/>
           </a:xfrm>
           <a:prstGeom prst="rect">
             <a:avLst/>
@@ -3933,30 +3634,27 @@
               <a:buNone/>
             </a:pPr>
             <a:r>
-              <a:rPr lang="en-US" sz="7200" b="1" dirty="0">
-                <a:solidFill>
-                  <a:schemeClr val="accent1"/>
-                </a:solidFill>
-                <a:latin typeface="Cambria" pitchFamily="34" charset="0"/>
-                <a:ea typeface="Cambria" pitchFamily="34" charset="-122"/>
-                <a:cs typeface="Cambria" pitchFamily="34" charset="-120"/>
-              </a:rPr>
-              <a:t>“</a:t>
-            </a:r>
-            <a:endParaRPr lang="en-US" sz="7200" dirty="0"/>
-          </a:p>
-        </p:txBody>
-      </p:sp>
-      <p:sp>
-        <p:nvSpPr>
-          <p:cNvPr id="27" name="Quote"/>
+              <a:rPr lang="en-US" sz="1600" b="1" dirty="0">
+                <a:solidFill>
+                  <a:schemeClr val="bg1"/>
+                </a:solidFill>
+              </a:rPr>
+              <a:t>Appearance</a:t>
+            </a:r>
+            <a:endParaRPr lang="en-US" sz="1600" dirty="0"/>
+          </a:p>
+        </p:txBody>
+      </p:sp>
+      <p:sp>
+        <p:nvSpPr>
+          <p:cNvPr id="17" name="Appearance text"/>
           <p:cNvSpPr txBox="1"/>
           <p:nvPr/>
         </p:nvSpPr>
         <p:spPr>
           <a:xfrm>
-            <a:off x="5989320" y="2011680"/>
-            <a:ext cx="2468880" cy="1463040"/>
+            <a:off x="2834640" y="1874520"/>
+            <a:ext cx="2514600" cy="365760"/>
           </a:xfrm>
           <a:prstGeom prst="rect">
             <a:avLst/>
@@ -3969,33 +3667,128 @@
           <a:lstStyle/>
           <a:p>
             <a:pPr indent="0" marL="0">
-              <a:buNone/>
-            </a:pPr>
-            <a:r>
-              <a:rPr lang="en-US" sz="1800" i="1" dirty="0">
+              <a:spcAft>
+                <a:spcPts val="1000"/>
+              </a:spcAft>
+              <a:buNone/>
+            </a:pPr>
+            <a:r>
+              <a:rPr lang="en-US" sz="1400" dirty="0">
                 <a:solidFill>
                   <a:schemeClr val="bg1"/>
                 </a:solidFill>
-                <a:latin typeface="Cambria" pitchFamily="34" charset="0"/>
-                <a:ea typeface="Cambria" pitchFamily="34" charset="-122"/>
-                <a:cs typeface="Cambria" pitchFamily="34" charset="-120"/>
-              </a:rPr>
-              <a:t>I didn’t like Trevor enough to call him ‘Worth Loving.’</a:t>
-            </a:r>
-            <a:endParaRPr lang="en-US" sz="1800" dirty="0"/>
-          </a:p>
-        </p:txBody>
-      </p:sp>
-      <p:sp>
-        <p:nvSpPr>
-          <p:cNvPr id="28" name="Quote takeaway"/>
+              </a:rPr>
+              <a:t>Curly, messy hair</a:t>
+            </a:r>
+            <a:br/>
+            <a:pPr indent="0" marL="0">
+              <a:buNone/>
+            </a:pPr>
+            <a:r>
+              <a:rPr lang="en-US" sz="1200" i="1" dirty="0">
+                <a:solidFill>
+                  <a:schemeClr val="accent2"/>
+                </a:solidFill>
+              </a:rPr>
+              <a:t>“curls that never looked combed”</a:t>
+            </a:r>
+            <a:endParaRPr lang="en-US" sz="1400" dirty="0"/>
+          </a:p>
+        </p:txBody>
+      </p:sp>
+      <p:sp>
+        <p:nvSpPr>
+          <p:cNvPr id="18" name="Personal info card"/>
+          <p:cNvSpPr/>
+          <p:nvPr/>
+        </p:nvSpPr>
+        <p:spPr>
+          <a:xfrm>
+            <a:off x="2697480" y="2514600"/>
+            <a:ext cx="2788920" cy="2240280"/>
+          </a:xfrm>
+          <a:prstGeom prst="roundRect">
+            <a:avLst>
+              <a:gd name="adj" fmla="val 4898"/>
+            </a:avLst>
+          </a:prstGeom>
+          <a:solidFill>
+            <a:schemeClr val="tx2"/>
+          </a:solidFill>
+          <a:ln w="12700">
+            <a:solidFill>
+              <a:schemeClr val="tx2"/>
+            </a:solidFill>
+            <a:prstDash val="solid"/>
+          </a:ln>
+          <a:effectLst>
+            <a:outerShdw sx="100000" sy="100000" kx="0" ky="0" algn="bl" rotWithShape="0" blurRad="101600" dist="38100" dir="5400000">
+              <a:srgbClr val="000000">
+                <a:alpha val="35000"/>
+              </a:srgbClr>
+            </a:outerShdw>
+          </a:effectLst>
+        </p:spPr>
+      </p:sp>
+      <p:sp>
+        <p:nvSpPr>
+          <p:cNvPr id="19" name="Personal info circle"/>
+          <p:cNvSpPr/>
+          <p:nvPr/>
+        </p:nvSpPr>
+        <p:spPr>
+          <a:xfrm>
+            <a:off x="2880360" y="2679192"/>
+            <a:ext cx="411480" cy="411480"/>
+          </a:xfrm>
+          <a:prstGeom prst="ellipse">
+            <a:avLst/>
+          </a:prstGeom>
+          <a:solidFill>
+            <a:schemeClr val="accent4"/>
+          </a:solidFill>
+          <a:ln w="12700">
+            <a:solidFill>
+              <a:schemeClr val="accent4"/>
+            </a:solidFill>
+            <a:prstDash val="solid"/>
+          </a:ln>
+        </p:spPr>
+      </p:sp>
+      <p:pic>
+        <p:nvPicPr>
+          <p:cNvPr id="20" name="Personal info icon" descr="preencoded.png">    </p:cNvPr>
+          <p:cNvPicPr>
+            <a:picLocks noChangeAspect="1"/>
+          </p:cNvPicPr>
+          <p:nvPr/>
+        </p:nvPicPr>
+        <p:blipFill>
+          <a:blip r:embed="rId2"/>
+          <a:stretch>
+            <a:fillRect/>
+          </a:stretch>
+        </p:blipFill>
+        <p:spPr>
+          <a:xfrm>
+            <a:off x="2983230" y="2782062"/>
+            <a:ext cx="205740" cy="205740"/>
+          </a:xfrm>
+          <a:prstGeom prst="rect">
+            <a:avLst/>
+          </a:prstGeom>
+        </p:spPr>
+      </p:pic>
+      <p:sp>
+        <p:nvSpPr>
+          <p:cNvPr id="21" name="Personal info header"/>
           <p:cNvSpPr txBox="1"/>
           <p:nvPr/>
         </p:nvSpPr>
         <p:spPr>
           <a:xfrm>
-            <a:off x="5989320" y="3566160"/>
-            <a:ext cx="2468880" cy="822960"/>
+            <a:off x="3429000" y="2679192"/>
+            <a:ext cx="1874520" cy="411480"/>
           </a:xfrm>
           <a:prstGeom prst="rect">
             <a:avLst/>
@@ -4004,21 +3797,358 @@
           <a:ln/>
         </p:spPr>
         <p:txBody>
+          <a:bodyPr wrap="square" lIns="0" tIns="0" rIns="0" bIns="0" rtlCol="0" anchor="ctr"/>
+          <a:lstStyle/>
+          <a:p>
+            <a:pPr indent="0" marL="0">
+              <a:buNone/>
+            </a:pPr>
+            <a:r>
+              <a:rPr lang="en-US" sz="1600" b="1" dirty="0">
+                <a:solidFill>
+                  <a:schemeClr val="bg1"/>
+                </a:solidFill>
+              </a:rPr>
+              <a:t>Personal info</a:t>
+            </a:r>
+            <a:endParaRPr lang="en-US" sz="1600" dirty="0"/>
+          </a:p>
+        </p:txBody>
+      </p:sp>
+      <p:sp>
+        <p:nvSpPr>
+          <p:cNvPr id="22" name="Personal info text"/>
+          <p:cNvSpPr txBox="1"/>
+          <p:nvPr/>
+        </p:nvSpPr>
+        <p:spPr>
+          <a:xfrm>
+            <a:off x="2834640" y="3200400"/>
+            <a:ext cx="2514600" cy="1463040"/>
+          </a:xfrm>
+          <a:prstGeom prst="rect">
+            <a:avLst/>
+          </a:prstGeom>
+          <a:noFill/>
+          <a:ln/>
+        </p:spPr>
+        <p:txBody>
           <a:bodyPr wrap="square" lIns="0" tIns="0" rIns="0" bIns="0" rtlCol="0" anchor="t"/>
           <a:lstStyle/>
           <a:p>
             <a:pPr indent="0" marL="0">
-              <a:buNone/>
-            </a:pPr>
-            <a:r>
-              <a:rPr lang="en-US" sz="1200" dirty="0">
-                <a:solidFill>
-                  <a:schemeClr val="accent3"/>
-                </a:solidFill>
-              </a:rPr>
-              <a:t>→ The reader judges Trevor and the gift through Kelly’s feelings.</a:t>
-            </a:r>
-            <a:endParaRPr lang="en-US" sz="1200" dirty="0"/>
+              <a:spcAft>
+                <a:spcPts val="1000"/>
+              </a:spcAft>
+              <a:buNone/>
+            </a:pPr>
+            <a:r>
+              <a:rPr lang="en-US" sz="1400" dirty="0">
+                <a:solidFill>
+                  <a:schemeClr val="bg1"/>
+                </a:solidFill>
+              </a:rPr>
+              <a:t>Does track → athletic</a:t>
+            </a:r>
+            <a:br/>
+            <a:pPr indent="0" marL="0">
+              <a:buNone/>
+            </a:pPr>
+            <a:r>
+              <a:rPr lang="en-US" sz="1200" i="1" dirty="0">
+                <a:solidFill>
+                  <a:schemeClr val="accent2"/>
+                </a:solidFill>
+              </a:rPr>
+              <a:t>“I gotta show up for track practice”</a:t>
+            </a:r>
+            <a:endParaRPr lang="en-US" sz="1400" dirty="0"/>
+          </a:p>
+          <a:p>
+            <a:pPr indent="0" marL="0">
+              <a:spcAft>
+                <a:spcPts val="1000"/>
+              </a:spcAft>
+              <a:buNone/>
+            </a:pPr>
+            <a:r>
+              <a:rPr lang="en-US" sz="1400" dirty="0">
+                <a:solidFill>
+                  <a:schemeClr val="bg1"/>
+                </a:solidFill>
+              </a:rPr>
+              <a:t>Thief – stole the bracelet</a:t>
+            </a:r>
+            <a:br/>
+            <a:pPr indent="0" marL="0">
+              <a:buNone/>
+            </a:pPr>
+            <a:r>
+              <a:rPr lang="en-US" sz="1200" i="1" dirty="0">
+                <a:solidFill>
+                  <a:schemeClr val="accent2"/>
+                </a:solidFill>
+              </a:rPr>
+              <a:t>“he ‘jacked’ the bracelet”</a:t>
+            </a:r>
+            <a:endParaRPr lang="en-US" sz="1400" dirty="0"/>
+          </a:p>
+          <a:p>
+            <a:pPr indent="0" marL="0">
+              <a:spcAft>
+                <a:spcPts val="1000"/>
+              </a:spcAft>
+              <a:buNone/>
+            </a:pPr>
+            <a:r>
+              <a:rPr lang="en-US" sz="1400" dirty="0">
+                <a:solidFill>
+                  <a:schemeClr val="bg1"/>
+                </a:solidFill>
+              </a:rPr>
+              <a:t>Bad handwriting</a:t>
+            </a:r>
+            <a:br/>
+            <a:pPr indent="0" marL="0">
+              <a:buNone/>
+            </a:pPr>
+            <a:r>
+              <a:rPr lang="en-US" sz="1200" i="1" dirty="0">
+                <a:solidFill>
+                  <a:schemeClr val="accent2"/>
+                </a:solidFill>
+              </a:rPr>
+              <a:t>“the cramped style”</a:t>
+            </a:r>
+            <a:endParaRPr lang="en-US" sz="1400" dirty="0"/>
+          </a:p>
+        </p:txBody>
+      </p:sp>
+      <p:sp>
+        <p:nvSpPr>
+          <p:cNvPr id="23" name="Character card"/>
+          <p:cNvSpPr/>
+          <p:nvPr/>
+        </p:nvSpPr>
+        <p:spPr>
+          <a:xfrm>
+            <a:off x="5669280" y="1188720"/>
+            <a:ext cx="3017520" cy="3566160"/>
+          </a:xfrm>
+          <a:prstGeom prst="roundRect">
+            <a:avLst>
+              <a:gd name="adj" fmla="val 3636"/>
+            </a:avLst>
+          </a:prstGeom>
+          <a:solidFill>
+            <a:schemeClr val="tx2"/>
+          </a:solidFill>
+          <a:ln w="12700">
+            <a:solidFill>
+              <a:schemeClr val="tx2"/>
+            </a:solidFill>
+            <a:prstDash val="solid"/>
+          </a:ln>
+          <a:effectLst>
+            <a:outerShdw sx="100000" sy="100000" kx="0" ky="0" algn="bl" rotWithShape="0" blurRad="101600" dist="38100" dir="5400000">
+              <a:srgbClr val="000000">
+                <a:alpha val="35000"/>
+              </a:srgbClr>
+            </a:outerShdw>
+          </a:effectLst>
+        </p:spPr>
+      </p:sp>
+      <p:sp>
+        <p:nvSpPr>
+          <p:cNvPr id="24" name="Character circle"/>
+          <p:cNvSpPr/>
+          <p:nvPr/>
+        </p:nvSpPr>
+        <p:spPr>
+          <a:xfrm>
+            <a:off x="5852160" y="1353312"/>
+            <a:ext cx="411480" cy="411480"/>
+          </a:xfrm>
+          <a:prstGeom prst="ellipse">
+            <a:avLst/>
+          </a:prstGeom>
+          <a:solidFill>
+            <a:schemeClr val="accent4"/>
+          </a:solidFill>
+          <a:ln w="12700">
+            <a:solidFill>
+              <a:schemeClr val="accent4"/>
+            </a:solidFill>
+            <a:prstDash val="solid"/>
+          </a:ln>
+        </p:spPr>
+      </p:sp>
+      <p:pic>
+        <p:nvPicPr>
+          <p:cNvPr id="25" name="Character icon" descr="preencoded.png">    </p:cNvPr>
+          <p:cNvPicPr>
+            <a:picLocks noChangeAspect="1"/>
+          </p:cNvPicPr>
+          <p:nvPr/>
+        </p:nvPicPr>
+        <p:blipFill>
+          <a:blip r:embed="rId3"/>
+          <a:stretch>
+            <a:fillRect/>
+          </a:stretch>
+        </p:blipFill>
+        <p:spPr>
+          <a:xfrm>
+            <a:off x="5955030" y="1456182"/>
+            <a:ext cx="205740" cy="205740"/>
+          </a:xfrm>
+          <a:prstGeom prst="rect">
+            <a:avLst/>
+          </a:prstGeom>
+        </p:spPr>
+      </p:pic>
+      <p:sp>
+        <p:nvSpPr>
+          <p:cNvPr id="26" name="Character header"/>
+          <p:cNvSpPr txBox="1"/>
+          <p:nvPr/>
+        </p:nvSpPr>
+        <p:spPr>
+          <a:xfrm>
+            <a:off x="6400800" y="1353312"/>
+            <a:ext cx="2103120" cy="411480"/>
+          </a:xfrm>
+          <a:prstGeom prst="rect">
+            <a:avLst/>
+          </a:prstGeom>
+          <a:noFill/>
+          <a:ln/>
+        </p:spPr>
+        <p:txBody>
+          <a:bodyPr wrap="square" lIns="0" tIns="0" rIns="0" bIns="0" rtlCol="0" anchor="ctr"/>
+          <a:lstStyle/>
+          <a:p>
+            <a:pPr indent="0" marL="0">
+              <a:buNone/>
+            </a:pPr>
+            <a:r>
+              <a:rPr lang="en-US" sz="1600" b="1" dirty="0">
+                <a:solidFill>
+                  <a:schemeClr val="bg1"/>
+                </a:solidFill>
+              </a:rPr>
+              <a:t>Character</a:t>
+            </a:r>
+            <a:endParaRPr lang="en-US" sz="1600" dirty="0"/>
+          </a:p>
+        </p:txBody>
+      </p:sp>
+      <p:sp>
+        <p:nvSpPr>
+          <p:cNvPr id="27" name="Character text"/>
+          <p:cNvSpPr txBox="1"/>
+          <p:nvPr/>
+        </p:nvSpPr>
+        <p:spPr>
+          <a:xfrm>
+            <a:off x="5806440" y="1874520"/>
+            <a:ext cx="2743200" cy="2788920"/>
+          </a:xfrm>
+          <a:prstGeom prst="rect">
+            <a:avLst/>
+          </a:prstGeom>
+          <a:noFill/>
+          <a:ln/>
+        </p:spPr>
+        <p:txBody>
+          <a:bodyPr wrap="square" lIns="0" tIns="0" rIns="0" bIns="0" rtlCol="0" anchor="t"/>
+          <a:lstStyle/>
+          <a:p>
+            <a:pPr indent="0" marL="0">
+              <a:spcAft>
+                <a:spcPts val="1000"/>
+              </a:spcAft>
+              <a:buNone/>
+            </a:pPr>
+            <a:r>
+              <a:rPr lang="en-US" sz="1400" dirty="0">
+                <a:solidFill>
+                  <a:schemeClr val="bg1"/>
+                </a:solidFill>
+              </a:rPr>
+              <a:t>Quiet, doesn’t talk much</a:t>
+            </a:r>
+            <a:br/>
+            <a:pPr indent="0" marL="0">
+              <a:buNone/>
+            </a:pPr>
+            <a:r>
+              <a:rPr lang="en-US" sz="1200" i="1" dirty="0">
+                <a:solidFill>
+                  <a:schemeClr val="accent2"/>
+                </a:solidFill>
+              </a:rPr>
+              <a:t>“Trevor was a guy of few words.”</a:t>
+            </a:r>
+            <a:endParaRPr lang="en-US" sz="1400" dirty="0"/>
+          </a:p>
+          <a:p>
+            <a:pPr indent="0" marL="0">
+              <a:spcAft>
+                <a:spcPts val="1000"/>
+              </a:spcAft>
+              <a:buNone/>
+            </a:pPr>
+            <a:r>
+              <a:rPr lang="en-US" sz="1400" dirty="0">
+                <a:solidFill>
+                  <a:schemeClr val="bg1"/>
+                </a:solidFill>
+              </a:rPr>
+              <a:t>Dishonest</a:t>
+            </a:r>
+            <a:br/>
+            <a:pPr indent="0" marL="0">
+              <a:buNone/>
+            </a:pPr>
+            <a:r>
+              <a:rPr lang="en-US" sz="1200" i="1" dirty="0">
+                <a:solidFill>
+                  <a:schemeClr val="accent2"/>
+                </a:solidFill>
+              </a:rPr>
+              <a:t>doesn’t tell Kelly the bracelet is stolen</a:t>
+            </a:r>
+            <a:endParaRPr lang="en-US" sz="1400" dirty="0"/>
+          </a:p>
+          <a:p>
+            <a:pPr indent="0" marL="0">
+              <a:spcAft>
+                <a:spcPts val="1000"/>
+              </a:spcAft>
+              <a:buNone/>
+            </a:pPr>
+            <a:r>
+              <a:rPr lang="en-US" sz="1400" dirty="0">
+                <a:solidFill>
+                  <a:schemeClr val="bg1"/>
+                </a:solidFill>
+              </a:rPr>
+              <a:t>Offhanded / confident</a:t>
+            </a:r>
+            <a:br/>
+            <a:pPr indent="0" marL="0">
+              <a:buNone/>
+            </a:pPr>
+            <a:r>
+              <a:rPr lang="en-US" sz="1200" i="1" dirty="0">
+                <a:solidFill>
+                  <a:schemeClr val="accent2"/>
+                </a:solidFill>
+              </a:rPr>
+              <a:t>“He spoke so offhandedly I was surprised.”</a:t>
+            </a:r>
+            <a:endParaRPr lang="en-US" sz="1400" dirty="0"/>
           </a:p>
         </p:txBody>
       </p:sp>
@@ -4124,7 +4254,7 @@
                   <a:schemeClr val="accent1"/>
                 </a:solidFill>
               </a:rPr>
-              <a:t>NARRATIVE PERSPECTIVE</a:t>
+              <a:t>CHARACTERIZATION</a:t>
             </a:r>
             <a:endParaRPr lang="en-US" sz="1100" dirty="0"/>
           </a:p>
@@ -4165,7 +4295,7 @@
                 <a:ea typeface="Cambria" pitchFamily="34" charset="-122"/>
                 <a:cs typeface="Cambria" pitchFamily="34" charset="-120"/>
               </a:rPr>
-              <a:t>Who tells the story?</a:t>
+              <a:t>Who is Kelly?</a:t>
             </a:r>
             <a:endParaRPr lang="en-US" sz="3400" dirty="0"/>
           </a:p>
@@ -4286,14 +4416,14 @@
       </p:sp>
       <p:sp>
         <p:nvSpPr>
-          <p:cNvPr id="9" name="Big I circle"/>
-          <p:cNvSpPr/>
-          <p:nvPr/>
-        </p:nvSpPr>
-        <p:spPr>
-          <a:xfrm>
-            <a:off x="640080" y="1325880"/>
-            <a:ext cx="2377440" cy="2377440"/>
+          <p:cNvPr id="9" name="Portrait circle"/>
+          <p:cNvSpPr/>
+          <p:nvPr/>
+        </p:nvSpPr>
+        <p:spPr>
+          <a:xfrm>
+            <a:off x="548640" y="1371600"/>
+            <a:ext cx="1737360" cy="1737360"/>
           </a:xfrm>
           <a:prstGeom prst="ellipse">
             <a:avLst/>
@@ -4311,14 +4441,14 @@
       </p:sp>
       <p:sp>
         <p:nvSpPr>
-          <p:cNvPr id="10" name="Big I"/>
+          <p:cNvPr id="10" name="Portrait initial"/>
           <p:cNvSpPr txBox="1"/>
           <p:nvPr/>
         </p:nvSpPr>
         <p:spPr>
           <a:xfrm>
-            <a:off x="640080" y="1325880"/>
-            <a:ext cx="2377440" cy="2377440"/>
+            <a:off x="548640" y="1371600"/>
+            <a:ext cx="1737360" cy="1737360"/>
           </a:xfrm>
           <a:prstGeom prst="rect">
             <a:avLst/>
@@ -4334,7 +4464,7 @@
               <a:buNone/>
             </a:pPr>
             <a:r>
-              <a:rPr lang="en-US" sz="8000" b="1" i="1" dirty="0">
+              <a:rPr lang="en-US" sz="7200" b="1" dirty="0">
                 <a:solidFill>
                   <a:schemeClr val="bg1"/>
                 </a:solidFill>
@@ -4342,22 +4472,22 @@
                 <a:ea typeface="Cambria" pitchFamily="34" charset="-122"/>
                 <a:cs typeface="Cambria" pitchFamily="34" charset="-120"/>
               </a:rPr>
-              <a:t>“I”</a:t>
-            </a:r>
-            <a:endParaRPr lang="en-US" sz="8000" dirty="0"/>
-          </a:p>
-        </p:txBody>
-      </p:sp>
-      <p:sp>
-        <p:nvSpPr>
-          <p:cNvPr id="11" name="Big I label"/>
+              <a:t>K</a:t>
+            </a:r>
+            <a:endParaRPr lang="en-US" sz="7200" dirty="0"/>
+          </a:p>
+        </p:txBody>
+      </p:sp>
+      <p:sp>
+        <p:nvSpPr>
+          <p:cNvPr id="11" name="Name"/>
           <p:cNvSpPr txBox="1"/>
           <p:nvPr/>
         </p:nvSpPr>
         <p:spPr>
           <a:xfrm>
-            <a:off x="365760" y="3840480"/>
-            <a:ext cx="2926080" cy="365760"/>
+            <a:off x="365760" y="3291840"/>
+            <a:ext cx="2103120" cy="365760"/>
           </a:xfrm>
           <a:prstGeom prst="rect">
             <a:avLst/>
@@ -4373,27 +4503,27 @@
               <a:buNone/>
             </a:pPr>
             <a:r>
-              <a:rPr lang="en-US" sz="1800" b="1" dirty="0">
+              <a:rPr lang="en-US" sz="2000" b="1" dirty="0">
                 <a:solidFill>
                   <a:schemeClr val="bg1"/>
                 </a:solidFill>
               </a:rPr>
-              <a:t>First-person narrator</a:t>
-            </a:r>
-            <a:endParaRPr lang="en-US" sz="1800" dirty="0"/>
-          </a:p>
-        </p:txBody>
-      </p:sp>
-      <p:sp>
-        <p:nvSpPr>
-          <p:cNvPr id="12" name="Big I caption"/>
+              <a:t>Kelly</a:t>
+            </a:r>
+            <a:endParaRPr lang="en-US" sz="2000" dirty="0"/>
+          </a:p>
+        </p:txBody>
+      </p:sp>
+      <p:sp>
+        <p:nvSpPr>
+          <p:cNvPr id="12" name="Role"/>
           <p:cNvSpPr txBox="1"/>
           <p:nvPr/>
         </p:nvSpPr>
         <p:spPr>
           <a:xfrm>
-            <a:off x="365760" y="4206240"/>
-            <a:ext cx="2926080" cy="320040"/>
+            <a:off x="365760" y="3657600"/>
+            <a:ext cx="2103120" cy="548640"/>
           </a:xfrm>
           <a:prstGeom prst="rect">
             <a:avLst/>
@@ -4402,38 +4532,38 @@
           <a:ln/>
         </p:spPr>
         <p:txBody>
-          <a:bodyPr wrap="square" lIns="0" tIns="0" rIns="0" bIns="0" rtlCol="0" anchor="ctr"/>
+          <a:bodyPr wrap="square" lIns="0" tIns="0" rIns="0" bIns="0" rtlCol="0" anchor="t"/>
           <a:lstStyle/>
           <a:p>
             <a:pPr algn="ctr" indent="0" marL="0">
               <a:buNone/>
             </a:pPr>
             <a:r>
-              <a:rPr lang="en-US" sz="1300" dirty="0">
+              <a:rPr lang="en-US" sz="1200" dirty="0">
                 <a:solidFill>
                   <a:schemeClr val="accent2"/>
                 </a:solidFill>
               </a:rPr>
-              <a:t>Kelly, the 16-year-old protagonist</a:t>
-            </a:r>
-            <a:endParaRPr lang="en-US" sz="1300" dirty="0"/>
-          </a:p>
-        </p:txBody>
-      </p:sp>
-      <p:sp>
-        <p:nvSpPr>
-          <p:cNvPr id="13" name="Features card"/>
-          <p:cNvSpPr/>
-          <p:nvPr/>
-        </p:nvSpPr>
-        <p:spPr>
-          <a:xfrm>
-            <a:off x="3749040" y="1188720"/>
-            <a:ext cx="4937760" cy="3520440"/>
+              <a:t>Protagonist &amp; first-person narrator</a:t>
+            </a:r>
+            <a:endParaRPr lang="en-US" sz="1200" dirty="0"/>
+          </a:p>
+        </p:txBody>
+      </p:sp>
+      <p:sp>
+        <p:nvSpPr>
+          <p:cNvPr id="13" name="Appearance card"/>
+          <p:cNvSpPr/>
+          <p:nvPr/>
+        </p:nvSpPr>
+        <p:spPr>
+          <a:xfrm>
+            <a:off x="2697480" y="1188720"/>
+            <a:ext cx="2788920" cy="1143000"/>
           </a:xfrm>
           <a:prstGeom prst="roundRect">
             <a:avLst>
-              <a:gd name="adj" fmla="val 3117"/>
+              <a:gd name="adj" fmla="val 9600"/>
             </a:avLst>
           </a:prstGeom>
           <a:solidFill>
@@ -4456,14 +4586,63 @@
       </p:sp>
       <p:sp>
         <p:nvSpPr>
-          <p:cNvPr id="14" name="Perspective features"/>
+          <p:cNvPr id="14" name="Appearance circle"/>
+          <p:cNvSpPr/>
+          <p:nvPr/>
+        </p:nvSpPr>
+        <p:spPr>
+          <a:xfrm>
+            <a:off x="2880360" y="1353312"/>
+            <a:ext cx="411480" cy="411480"/>
+          </a:xfrm>
+          <a:prstGeom prst="ellipse">
+            <a:avLst/>
+          </a:prstGeom>
+          <a:solidFill>
+            <a:schemeClr val="accent1"/>
+          </a:solidFill>
+          <a:ln w="12700">
+            <a:solidFill>
+              <a:schemeClr val="accent1"/>
+            </a:solidFill>
+            <a:prstDash val="solid"/>
+          </a:ln>
+        </p:spPr>
+      </p:sp>
+      <p:pic>
+        <p:nvPicPr>
+          <p:cNvPr id="15" name="Appearance icon" descr="preencoded.png">    </p:cNvPr>
+          <p:cNvPicPr>
+            <a:picLocks noChangeAspect="1"/>
+          </p:cNvPicPr>
+          <p:nvPr/>
+        </p:nvPicPr>
+        <p:blipFill>
+          <a:blip r:embed="rId1"/>
+          <a:stretch>
+            <a:fillRect/>
+          </a:stretch>
+        </p:blipFill>
+        <p:spPr>
+          <a:xfrm>
+            <a:off x="2983230" y="1456182"/>
+            <a:ext cx="205740" cy="205740"/>
+          </a:xfrm>
+          <a:prstGeom prst="rect">
+            <a:avLst/>
+          </a:prstGeom>
+        </p:spPr>
+      </p:pic>
+      <p:sp>
+        <p:nvSpPr>
+          <p:cNvPr id="16" name="Appearance header"/>
           <p:cNvSpPr txBox="1"/>
           <p:nvPr/>
         </p:nvSpPr>
         <p:spPr>
           <a:xfrm>
-            <a:off x="3977640" y="1325880"/>
-            <a:ext cx="4480560" cy="3246120"/>
+            <a:off x="3429000" y="1353312"/>
+            <a:ext cx="1874520" cy="411480"/>
           </a:xfrm>
           <a:prstGeom prst="rect">
             <a:avLst/>
@@ -4472,131 +4651,504 @@
           <a:ln/>
         </p:spPr>
         <p:txBody>
+          <a:bodyPr wrap="square" lIns="0" tIns="0" rIns="0" bIns="0" rtlCol="0" anchor="ctr"/>
+          <a:lstStyle/>
+          <a:p>
+            <a:pPr indent="0" marL="0">
+              <a:buNone/>
+            </a:pPr>
+            <a:r>
+              <a:rPr lang="en-US" sz="1600" b="1" dirty="0">
+                <a:solidFill>
+                  <a:schemeClr val="bg1"/>
+                </a:solidFill>
+              </a:rPr>
+              <a:t>Appearance</a:t>
+            </a:r>
+            <a:endParaRPr lang="en-US" sz="1600" dirty="0"/>
+          </a:p>
+        </p:txBody>
+      </p:sp>
+      <p:sp>
+        <p:nvSpPr>
+          <p:cNvPr id="17" name="Appearance text"/>
+          <p:cNvSpPr txBox="1"/>
+          <p:nvPr/>
+        </p:nvSpPr>
+        <p:spPr>
+          <a:xfrm>
+            <a:off x="2834640" y="1874520"/>
+            <a:ext cx="2514600" cy="365760"/>
+          </a:xfrm>
+          <a:prstGeom prst="rect">
+            <a:avLst/>
+          </a:prstGeom>
+          <a:noFill/>
+          <a:ln/>
+        </p:spPr>
+        <p:txBody>
           <a:bodyPr wrap="square" lIns="0" tIns="0" rIns="0" bIns="0" rtlCol="0" anchor="t"/>
           <a:lstStyle/>
           <a:p>
             <a:pPr indent="0" marL="0">
-              <a:buNone/>
-            </a:pPr>
-            <a:r>
-              <a:rPr lang="en-US" sz="1700" b="1" dirty="0">
-                <a:solidFill>
-                  <a:schemeClr val="accent1"/>
-                </a:solidFill>
-              </a:rPr>
-              <a:t>Participating narrator</a:t>
-            </a:r>
-            <a:endParaRPr lang="en-US" sz="1700" dirty="0"/>
-          </a:p>
+              <a:spcAft>
+                <a:spcPts val="1000"/>
+              </a:spcAft>
+              <a:buNone/>
+            </a:pPr>
+            <a:r>
+              <a:rPr lang="en-US" sz="1400" dirty="0">
+                <a:solidFill>
+                  <a:schemeClr val="bg1"/>
+                </a:solidFill>
+              </a:rPr>
+              <a:t>Not described</a:t>
+            </a:r>
+            <a:br/>
+            <a:pPr indent="0" marL="0">
+              <a:buNone/>
+            </a:pPr>
+            <a:r>
+              <a:rPr lang="en-US" sz="1200" i="1" dirty="0">
+                <a:solidFill>
+                  <a:schemeClr val="accent2"/>
+                </a:solidFill>
+              </a:rPr>
+              <a:t>we only see through her eyes</a:t>
+            </a:r>
+            <a:endParaRPr lang="en-US" sz="1400" dirty="0"/>
+          </a:p>
+        </p:txBody>
+      </p:sp>
+      <p:sp>
+        <p:nvSpPr>
+          <p:cNvPr id="18" name="Personal info card"/>
+          <p:cNvSpPr/>
+          <p:nvPr/>
+        </p:nvSpPr>
+        <p:spPr>
+          <a:xfrm>
+            <a:off x="2697480" y="2514600"/>
+            <a:ext cx="2788920" cy="2240280"/>
+          </a:xfrm>
+          <a:prstGeom prst="roundRect">
+            <a:avLst>
+              <a:gd name="adj" fmla="val 4898"/>
+            </a:avLst>
+          </a:prstGeom>
+          <a:solidFill>
+            <a:schemeClr val="tx2"/>
+          </a:solidFill>
+          <a:ln w="12700">
+            <a:solidFill>
+              <a:schemeClr val="tx2"/>
+            </a:solidFill>
+            <a:prstDash val="solid"/>
+          </a:ln>
+          <a:effectLst>
+            <a:outerShdw sx="100000" sy="100000" kx="0" ky="0" algn="bl" rotWithShape="0" blurRad="101600" dist="38100" dir="5400000">
+              <a:srgbClr val="000000">
+                <a:alpha val="35000"/>
+              </a:srgbClr>
+            </a:outerShdw>
+          </a:effectLst>
+        </p:spPr>
+      </p:sp>
+      <p:sp>
+        <p:nvSpPr>
+          <p:cNvPr id="19" name="Personal info circle"/>
+          <p:cNvSpPr/>
+          <p:nvPr/>
+        </p:nvSpPr>
+        <p:spPr>
+          <a:xfrm>
+            <a:off x="2880360" y="2679192"/>
+            <a:ext cx="411480" cy="411480"/>
+          </a:xfrm>
+          <a:prstGeom prst="ellipse">
+            <a:avLst/>
+          </a:prstGeom>
+          <a:solidFill>
+            <a:schemeClr val="accent1"/>
+          </a:solidFill>
+          <a:ln w="12700">
+            <a:solidFill>
+              <a:schemeClr val="accent1"/>
+            </a:solidFill>
+            <a:prstDash val="solid"/>
+          </a:ln>
+        </p:spPr>
+      </p:sp>
+      <p:pic>
+        <p:nvPicPr>
+          <p:cNvPr id="20" name="Personal info icon" descr="preencoded.png">    </p:cNvPr>
+          <p:cNvPicPr>
+            <a:picLocks noChangeAspect="1"/>
+          </p:cNvPicPr>
+          <p:nvPr/>
+        </p:nvPicPr>
+        <p:blipFill>
+          <a:blip r:embed="rId2"/>
+          <a:stretch>
+            <a:fillRect/>
+          </a:stretch>
+        </p:blipFill>
+        <p:spPr>
+          <a:xfrm>
+            <a:off x="2983230" y="2782062"/>
+            <a:ext cx="205740" cy="205740"/>
+          </a:xfrm>
+          <a:prstGeom prst="rect">
+            <a:avLst/>
+          </a:prstGeom>
+        </p:spPr>
+      </p:pic>
+      <p:sp>
+        <p:nvSpPr>
+          <p:cNvPr id="21" name="Personal info header"/>
+          <p:cNvSpPr txBox="1"/>
+          <p:nvPr/>
+        </p:nvSpPr>
+        <p:spPr>
+          <a:xfrm>
+            <a:off x="3429000" y="2679192"/>
+            <a:ext cx="1874520" cy="411480"/>
+          </a:xfrm>
+          <a:prstGeom prst="rect">
+            <a:avLst/>
+          </a:prstGeom>
+          <a:noFill/>
+          <a:ln/>
+        </p:spPr>
+        <p:txBody>
+          <a:bodyPr wrap="square" lIns="0" tIns="0" rIns="0" bIns="0" rtlCol="0" anchor="ctr"/>
+          <a:lstStyle/>
+          <a:p>
+            <a:pPr indent="0" marL="0">
+              <a:buNone/>
+            </a:pPr>
+            <a:r>
+              <a:rPr lang="en-US" sz="1600" b="1" dirty="0">
+                <a:solidFill>
+                  <a:schemeClr val="bg1"/>
+                </a:solidFill>
+              </a:rPr>
+              <a:t>Personal info</a:t>
+            </a:r>
+            <a:endParaRPr lang="en-US" sz="1600" dirty="0"/>
+          </a:p>
+        </p:txBody>
+      </p:sp>
+      <p:sp>
+        <p:nvSpPr>
+          <p:cNvPr id="22" name="Personal info text"/>
+          <p:cNvSpPr txBox="1"/>
+          <p:nvPr/>
+        </p:nvSpPr>
+        <p:spPr>
+          <a:xfrm>
+            <a:off x="2834640" y="3200400"/>
+            <a:ext cx="2514600" cy="1463040"/>
+          </a:xfrm>
+          <a:prstGeom prst="rect">
+            <a:avLst/>
+          </a:prstGeom>
+          <a:noFill/>
+          <a:ln/>
+        </p:spPr>
+        <p:txBody>
+          <a:bodyPr wrap="square" lIns="0" tIns="0" rIns="0" bIns="0" rtlCol="0" anchor="t"/>
+          <a:lstStyle/>
           <a:p>
             <a:pPr indent="0" marL="0">
               <a:spcAft>
-                <a:spcPts val="1200"/>
+                <a:spcPts val="1000"/>
               </a:spcAft>
               <a:buNone/>
             </a:pPr>
             <a:r>
-              <a:rPr lang="en-US" sz="1500" dirty="0">
+              <a:rPr lang="en-US" sz="1400" dirty="0">
                 <a:solidFill>
                   <a:schemeClr val="bg1"/>
                 </a:solidFill>
               </a:rPr>
-              <a:t>Kelly tells her own story and takes part in the action.</a:t>
-            </a:r>
-            <a:endParaRPr lang="en-US" sz="1700" dirty="0"/>
-          </a:p>
-          <a:p>
+              <a:t>Sixteen</a:t>
+            </a:r>
+            <a:br/>
             <a:pPr indent="0" marL="0">
               <a:buNone/>
             </a:pPr>
             <a:r>
-              <a:rPr lang="en-US" sz="1700" b="1" dirty="0">
-                <a:solidFill>
-                  <a:schemeClr val="accent1"/>
-                </a:solidFill>
-              </a:rPr>
-              <a:t>Limited point of view</a:t>
-            </a:r>
-            <a:endParaRPr lang="en-US" sz="1700" dirty="0"/>
+              <a:rPr lang="en-US" sz="1200" i="1" dirty="0">
+                <a:solidFill>
+                  <a:schemeClr val="accent2"/>
+                </a:solidFill>
+              </a:rPr>
+              <a:t>“Oh, sixteen.”</a:t>
+            </a:r>
+            <a:endParaRPr lang="en-US" sz="1400" dirty="0"/>
           </a:p>
           <a:p>
             <a:pPr indent="0" marL="0">
               <a:spcAft>
-                <a:spcPts val="1200"/>
+                <a:spcPts val="1000"/>
               </a:spcAft>
               <a:buNone/>
             </a:pPr>
             <a:r>
-              <a:rPr lang="en-US" sz="1500" dirty="0">
+              <a:rPr lang="en-US" sz="1400" dirty="0">
                 <a:solidFill>
                   <a:schemeClr val="bg1"/>
                 </a:solidFill>
               </a:rPr>
-              <a:t>Only her thoughts are known; Trevor and Kat are shown through dialogue and actions.</a:t>
-            </a:r>
-            <a:endParaRPr lang="en-US" sz="1700" dirty="0"/>
-          </a:p>
-          <a:p>
-            <a:pPr indent="0" marL="0">
-              <a:buNone/>
-            </a:pPr>
-            <a:r>
-              <a:rPr lang="en-US" sz="1700" b="1" dirty="0">
-                <a:solidFill>
-                  <a:schemeClr val="accent1"/>
-                </a:solidFill>
-              </a:rPr>
-              <a:t>Past tense</a:t>
-            </a:r>
-            <a:endParaRPr lang="en-US" sz="1700" dirty="0"/>
+              <a:t>Lives with mom &amp; younger twins Josh &amp; Will</a:t>
+            </a:r>
+            <a:endParaRPr lang="en-US" sz="1400" dirty="0"/>
           </a:p>
           <a:p>
             <a:pPr indent="0" marL="0">
               <a:spcAft>
-                <a:spcPts val="1200"/>
+                <a:spcPts val="1000"/>
               </a:spcAft>
               <a:buNone/>
             </a:pPr>
             <a:r>
-              <a:rPr lang="en-US" sz="1500" dirty="0">
+              <a:rPr lang="en-US" sz="1400" dirty="0">
                 <a:solidFill>
                   <a:schemeClr val="bg1"/>
                 </a:solidFill>
               </a:rPr>
-              <a:t>“I opened my palm to reveal a silver charm bracelet.”</a:t>
-            </a:r>
-            <a:endParaRPr lang="en-US" sz="1700" dirty="0"/>
-          </a:p>
+              <a:t>Aunt Joanie &amp; best friend Kat</a:t>
+            </a:r>
+            <a:endParaRPr lang="en-US" sz="1400" dirty="0"/>
+          </a:p>
+        </p:txBody>
+      </p:sp>
+      <p:sp>
+        <p:nvSpPr>
+          <p:cNvPr id="23" name="Character card"/>
+          <p:cNvSpPr/>
+          <p:nvPr/>
+        </p:nvSpPr>
+        <p:spPr>
+          <a:xfrm>
+            <a:off x="5669280" y="1188720"/>
+            <a:ext cx="3017520" cy="3566160"/>
+          </a:xfrm>
+          <a:prstGeom prst="roundRect">
+            <a:avLst>
+              <a:gd name="adj" fmla="val 3636"/>
+            </a:avLst>
+          </a:prstGeom>
+          <a:solidFill>
+            <a:schemeClr val="tx2"/>
+          </a:solidFill>
+          <a:ln w="12700">
+            <a:solidFill>
+              <a:schemeClr val="tx2"/>
+            </a:solidFill>
+            <a:prstDash val="solid"/>
+          </a:ln>
+          <a:effectLst>
+            <a:outerShdw sx="100000" sy="100000" kx="0" ky="0" algn="bl" rotWithShape="0" blurRad="101600" dist="38100" dir="5400000">
+              <a:srgbClr val="000000">
+                <a:alpha val="35000"/>
+              </a:srgbClr>
+            </a:outerShdw>
+          </a:effectLst>
+        </p:spPr>
+      </p:sp>
+      <p:sp>
+        <p:nvSpPr>
+          <p:cNvPr id="24" name="Character circle"/>
+          <p:cNvSpPr/>
+          <p:nvPr/>
+        </p:nvSpPr>
+        <p:spPr>
+          <a:xfrm>
+            <a:off x="5852160" y="1353312"/>
+            <a:ext cx="411480" cy="411480"/>
+          </a:xfrm>
+          <a:prstGeom prst="ellipse">
+            <a:avLst/>
+          </a:prstGeom>
+          <a:solidFill>
+            <a:schemeClr val="accent1"/>
+          </a:solidFill>
+          <a:ln w="12700">
+            <a:solidFill>
+              <a:schemeClr val="accent1"/>
+            </a:solidFill>
+            <a:prstDash val="solid"/>
+          </a:ln>
+        </p:spPr>
+      </p:sp>
+      <p:pic>
+        <p:nvPicPr>
+          <p:cNvPr id="25" name="Character icon" descr="preencoded.png">    </p:cNvPr>
+          <p:cNvPicPr>
+            <a:picLocks noChangeAspect="1"/>
+          </p:cNvPicPr>
+          <p:nvPr/>
+        </p:nvPicPr>
+        <p:blipFill>
+          <a:blip r:embed="rId3"/>
+          <a:stretch>
+            <a:fillRect/>
+          </a:stretch>
+        </p:blipFill>
+        <p:spPr>
+          <a:xfrm>
+            <a:off x="5955030" y="1456182"/>
+            <a:ext cx="205740" cy="205740"/>
+          </a:xfrm>
+          <a:prstGeom prst="rect">
+            <a:avLst/>
+          </a:prstGeom>
+        </p:spPr>
+      </p:pic>
+      <p:sp>
+        <p:nvSpPr>
+          <p:cNvPr id="26" name="Character header"/>
+          <p:cNvSpPr txBox="1"/>
+          <p:nvPr/>
+        </p:nvSpPr>
+        <p:spPr>
+          <a:xfrm>
+            <a:off x="6400800" y="1353312"/>
+            <a:ext cx="2103120" cy="411480"/>
+          </a:xfrm>
+          <a:prstGeom prst="rect">
+            <a:avLst/>
+          </a:prstGeom>
+          <a:noFill/>
+          <a:ln/>
+        </p:spPr>
+        <p:txBody>
+          <a:bodyPr wrap="square" lIns="0" tIns="0" rIns="0" bIns="0" rtlCol="0" anchor="ctr"/>
+          <a:lstStyle/>
           <a:p>
             <a:pPr indent="0" marL="0">
               <a:buNone/>
             </a:pPr>
             <a:r>
-              <a:rPr lang="en-US" sz="1700" b="1" dirty="0">
-                <a:solidFill>
-                  <a:schemeClr val="accent1"/>
-                </a:solidFill>
-              </a:rPr>
-              <a:t>Inner thoughts</a:t>
-            </a:r>
-            <a:endParaRPr lang="en-US" sz="1700" dirty="0"/>
-          </a:p>
+              <a:rPr lang="en-US" sz="1600" b="1" dirty="0">
+                <a:solidFill>
+                  <a:schemeClr val="bg1"/>
+                </a:solidFill>
+              </a:rPr>
+              <a:t>Character</a:t>
+            </a:r>
+            <a:endParaRPr lang="en-US" sz="1600" dirty="0"/>
+          </a:p>
+        </p:txBody>
+      </p:sp>
+      <p:sp>
+        <p:nvSpPr>
+          <p:cNvPr id="27" name="Character text"/>
+          <p:cNvSpPr txBox="1"/>
+          <p:nvPr/>
+        </p:nvSpPr>
+        <p:spPr>
+          <a:xfrm>
+            <a:off x="5806440" y="1874520"/>
+            <a:ext cx="2743200" cy="2788920"/>
+          </a:xfrm>
+          <a:prstGeom prst="rect">
+            <a:avLst/>
+          </a:prstGeom>
+          <a:noFill/>
+          <a:ln/>
+        </p:spPr>
+        <p:txBody>
+          <a:bodyPr wrap="square" lIns="0" tIns="0" rIns="0" bIns="0" rtlCol="0" anchor="t"/>
+          <a:lstStyle/>
           <a:p>
             <a:pPr indent="0" marL="0">
               <a:spcAft>
-                <a:spcPts val="1200"/>
+                <a:spcPts val="1000"/>
               </a:spcAft>
               <a:buNone/>
             </a:pPr>
             <a:r>
-              <a:rPr lang="en-US" sz="1500" dirty="0">
+              <a:rPr lang="en-US" sz="1400" dirty="0">
                 <a:solidFill>
                   <a:schemeClr val="bg1"/>
                 </a:solidFill>
               </a:rPr>
-              <a:t>“I imagined a sales clerk…” / “Come to think of it, I didn’t really like Kat all that much.”</a:t>
-            </a:r>
-            <a:endParaRPr lang="en-US" sz="1700" dirty="0"/>
+              <a:t>Emotional – touched by the bracelet</a:t>
+            </a:r>
+            <a:br/>
+            <a:pPr indent="0" marL="0">
+              <a:buNone/>
+            </a:pPr>
+            <a:r>
+              <a:rPr lang="en-US" sz="1200" i="1" dirty="0">
+                <a:solidFill>
+                  <a:schemeClr val="accent2"/>
+                </a:solidFill>
+              </a:rPr>
+              <a:t>“the blush that warmed my face”</a:t>
+            </a:r>
+            <a:endParaRPr lang="en-US" sz="1400" dirty="0"/>
+          </a:p>
+          <a:p>
+            <a:pPr indent="0" marL="0">
+              <a:spcAft>
+                <a:spcPts val="1000"/>
+              </a:spcAft>
+              <a:buNone/>
+            </a:pPr>
+            <a:r>
+              <a:rPr lang="en-US" sz="1400" dirty="0">
+                <a:solidFill>
+                  <a:schemeClr val="bg1"/>
+                </a:solidFill>
+              </a:rPr>
+              <a:t>Confused – uncertain about her feelings for Trevor</a:t>
+            </a:r>
+            <a:br/>
+            <a:pPr indent="0" marL="0">
+              <a:buNone/>
+            </a:pPr>
+            <a:r>
+              <a:rPr lang="en-US" sz="1200" i="1" dirty="0">
+                <a:solidFill>
+                  <a:schemeClr val="accent2"/>
+                </a:solidFill>
+              </a:rPr>
+              <a:t>“I wasn’t sure how I felt about him though.”</a:t>
+            </a:r>
+            <a:endParaRPr lang="en-US" sz="1400" dirty="0"/>
+          </a:p>
+          <a:p>
+            <a:pPr indent="0" marL="0">
+              <a:spcAft>
+                <a:spcPts val="1000"/>
+              </a:spcAft>
+              <a:buNone/>
+            </a:pPr>
+            <a:r>
+              <a:rPr lang="en-US" sz="1400" dirty="0">
+                <a:solidFill>
+                  <a:schemeClr val="bg1"/>
+                </a:solidFill>
+              </a:rPr>
+              <a:t>Thoughtful – thinks about the relationship</a:t>
+            </a:r>
+            <a:br/>
+            <a:pPr indent="0" marL="0">
+              <a:buNone/>
+            </a:pPr>
+            <a:r>
+              <a:rPr lang="en-US" sz="1200" i="1" dirty="0">
+                <a:solidFill>
+                  <a:schemeClr val="accent2"/>
+                </a:solidFill>
+              </a:rPr>
+              <a:t>“I wondered just what the value of this bracelet was to Trevor.”</a:t>
+            </a:r>
+            <a:endParaRPr lang="en-US" sz="1400" dirty="0"/>
           </a:p>
         </p:txBody>
       </p:sp>

</xml_diff>